<commit_message>
Add cluster map and secure email/OTP sign-in
</commit_message>
<xml_diff>
--- a/StudAI_Foundry_Season2_Pitch_SymbioLink_AI.pptx
+++ b/StudAI_Foundry_Season2_Pitch_SymbioLink_AI.pptx
@@ -4445,189 +4445,30 @@
           </a:p>
         </p:txBody>
       </p:sp>
-      <p:sp>
-        <p:nvSpPr>
-          <p:cNvPr id="54" name="Text 20"/>
-          <p:cNvSpPr/>
-          <p:nvPr/>
-        </p:nvSpPr>
-        <p:spPr>
-          <a:xfrm>
-            <a:off x="8046720" y="2743200"/>
-            <a:ext cx="2971440" cy="712800"/>
-          </a:xfrm>
-          <a:prstGeom prst="rect">
-            <a:avLst/>
-          </a:prstGeom>
-          <a:noFill/>
-          <a:ln w="0">
-            <a:noFill/>
-          </a:ln>
-        </p:spPr>
-        <p:style>
-          <a:lnRef idx="0"/>
-          <a:fillRef idx="0"/>
-          <a:effectRef idx="0"/>
-          <a:fontRef idx="minor"/>
-        </p:style>
-        <p:txBody>
-          <a:bodyPr lIns="0" rIns="0" tIns="0" bIns="0" anchor="ctr">
-            <a:normAutofit/>
-          </a:bodyPr>
-          <a:p>
-            <a:pPr algn="ctr" defTabSz="914400">
-              <a:lnSpc>
-                <a:spcPct val="100000"/>
-              </a:lnSpc>
-              <a:tabLst>
-                <a:tab algn="l" pos="0"/>
-              </a:tabLst>
-            </a:pPr>
-            <a:r>
-              <a:rPr b="1" lang="en-US" sz="1500" spc="-1" strike="noStrike">
-                <a:solidFill>
-                  <a:srgbClr val="93adcb"/>
-                </a:solidFill>
-                <a:latin typeface="Inter"/>
-                <a:ea typeface="Inter"/>
-              </a:rPr>
-              <a:t>DROP YOUR BEST</a:t>
-            </a:r>
-            <a:endParaRPr b="0" lang="en-US" sz="1500" spc="-1" strike="noStrike">
-              <a:solidFill>
-                <a:srgbClr val="ffffff"/>
-              </a:solidFill>
-              <a:latin typeface="Arial"/>
-            </a:endParaRPr>
-          </a:p>
-          <a:p>
-            <a:pPr algn="ctr" defTabSz="914400">
-              <a:lnSpc>
-                <a:spcPct val="100000"/>
-              </a:lnSpc>
-              <a:tabLst>
-                <a:tab algn="l" pos="0"/>
-              </a:tabLst>
-            </a:pPr>
-            <a:r>
-              <a:rPr b="1" lang="en-US" sz="1500" spc="-1" strike="noStrike">
-                <a:solidFill>
-                  <a:srgbClr val="93adcb"/>
-                </a:solidFill>
-                <a:latin typeface="Inter"/>
-                <a:ea typeface="Inter"/>
-              </a:rPr>
-              <a:t>PROJECT VISUAL HERE</a:t>
-            </a:r>
-            <a:endParaRPr b="0" lang="en-US" sz="1500" spc="-1" strike="noStrike">
-              <a:solidFill>
-                <a:srgbClr val="ffffff"/>
-              </a:solidFill>
-              <a:latin typeface="Arial"/>
-            </a:endParaRPr>
-          </a:p>
-        </p:txBody>
-      </p:sp>
-      <p:sp>
-        <p:nvSpPr>
-          <p:cNvPr id="55" name="Text 21"/>
-          <p:cNvSpPr/>
-          <p:nvPr/>
-        </p:nvSpPr>
-        <p:spPr>
-          <a:xfrm>
-            <a:off x="8119800" y="3639240"/>
-            <a:ext cx="2815920" cy="365400"/>
-          </a:xfrm>
-          <a:prstGeom prst="rect">
-            <a:avLst/>
-          </a:prstGeom>
-          <a:noFill/>
-          <a:ln w="0">
-            <a:noFill/>
-          </a:ln>
-        </p:spPr>
-        <p:style>
-          <a:lnRef idx="0"/>
-          <a:fillRef idx="0"/>
-          <a:effectRef idx="0"/>
-          <a:fontRef idx="minor"/>
-        </p:style>
-        <p:txBody>
-          <a:bodyPr lIns="0" rIns="0" tIns="0" bIns="0" anchor="ctr">
-            <a:normAutofit/>
-          </a:bodyPr>
-          <a:p>
-            <a:pPr algn="ctr" defTabSz="914400">
-              <a:lnSpc>
-                <a:spcPct val="100000"/>
-              </a:lnSpc>
-              <a:tabLst>
-                <a:tab algn="l" pos="0"/>
-              </a:tabLst>
-            </a:pPr>
-            <a:r>
-              <a:rPr b="0" lang="en-US" sz="939" spc="-1" strike="noStrike">
-                <a:solidFill>
-                  <a:srgbClr val="7392b5"/>
-                </a:solidFill>
-                <a:latin typeface="Roboto"/>
-                <a:ea typeface="Roboto"/>
-              </a:rPr>
-              <a:t>Product screen, prototype, photo or concept visual</a:t>
-            </a:r>
-            <a:endParaRPr b="0" lang="en-US" sz="939" spc="-1" strike="noStrike">
-              <a:solidFill>
-                <a:srgbClr val="ffffff"/>
-              </a:solidFill>
-              <a:latin typeface="Arial"/>
-            </a:endParaRPr>
-          </a:p>
-        </p:txBody>
-      </p:sp>
-      <p:sp>
-        <p:nvSpPr>
-          <p:cNvPr id="56" name="Shape 22"/>
-          <p:cNvSpPr/>
-          <p:nvPr/>
-        </p:nvSpPr>
-        <p:spPr>
-          <a:xfrm>
-            <a:off x="8092440" y="4224240"/>
-            <a:ext cx="2788920" cy="360"/>
-          </a:xfrm>
-          <a:prstGeom prst="line">
-            <a:avLst/>
-          </a:prstGeom>
-          <a:ln w="25400">
-            <a:solidFill>
-              <a:srgbClr val="009a4e">
-                <a:alpha val="80000"/>
-              </a:srgbClr>
-            </a:solidFill>
-            <a:round/>
-          </a:ln>
-        </p:spPr>
-        <p:style>
-          <a:lnRef idx="0"/>
-          <a:fillRef idx="0"/>
-          <a:effectRef idx="0"/>
-          <a:fontRef idx="minor"/>
-        </p:style>
-        <p:txBody>
-          <a:bodyPr lIns="90000" rIns="90000" tIns="-44640" bIns="-44640" anchor="t">
-            <a:noAutofit/>
-          </a:bodyPr>
-          <a:p>
-            <a:endParaRPr b="0" lang="en-US" sz="1800" spc="-1" strike="noStrike">
-              <a:solidFill>
-                <a:schemeClr val="dk1"/>
-              </a:solidFill>
-              <a:latin typeface="Roboto"/>
-            </a:endParaRPr>
-          </a:p>
-        </p:txBody>
-      </p:sp>
+      <p:pic>
+        <p:nvPicPr>
+          <p:cNvPr id="54" name="Picture 53" descr="dashboard.png"/>
+          <p:cNvPicPr>
+            <a:picLocks noChangeAspect="1"/>
+          </p:cNvPicPr>
+          <p:nvPr/>
+        </p:nvPicPr>
+        <p:blipFill>
+          <a:blip r:embed="rId3"/>
+          <a:stretch>
+            <a:fillRect/>
+          </a:stretch>
+        </p:blipFill>
+        <p:spPr>
+          <a:xfrm>
+            <a:off x="7845480" y="2703732"/>
+            <a:ext cx="3382920" cy="1614695"/>
+          </a:xfrm>
+          <a:prstGeom prst="rect">
+            <a:avLst/>
+          </a:prstGeom>
+        </p:spPr>
+      </p:pic>
     </p:spTree>
   </p:cSld>
   <mc:AlternateContent>
@@ -15770,120 +15611,6 @@
       </p:sp>
       <p:sp>
         <p:nvSpPr>
-          <p:cNvPr id="259" name="Text 26"/>
-          <p:cNvSpPr/>
-          <p:nvPr/>
-        </p:nvSpPr>
-        <p:spPr>
-          <a:xfrm>
-            <a:off x="7205400" y="3072240"/>
-            <a:ext cx="1554120" cy="228240"/>
-          </a:xfrm>
-          <a:prstGeom prst="rect">
-            <a:avLst/>
-          </a:prstGeom>
-          <a:noFill/>
-          <a:ln w="0">
-            <a:noFill/>
-          </a:ln>
-        </p:spPr>
-        <p:style>
-          <a:lnRef idx="0"/>
-          <a:fillRef idx="0"/>
-          <a:effectRef idx="0"/>
-          <a:fontRef idx="minor"/>
-        </p:style>
-        <p:txBody>
-          <a:bodyPr lIns="0" rIns="0" tIns="0" bIns="0" anchor="ctr">
-            <a:normAutofit fontScale="68333"/>
-          </a:bodyPr>
-          <a:p>
-            <a:pPr algn="ctr" defTabSz="914400">
-              <a:lnSpc>
-                <a:spcPct val="100000"/>
-              </a:lnSpc>
-              <a:tabLst>
-                <a:tab algn="l" pos="0"/>
-              </a:tabLst>
-            </a:pPr>
-            <a:r>
-              <a:rPr b="1" lang="en-US" sz="1200" spc="-1" strike="noStrike">
-                <a:solidFill>
-                  <a:srgbClr val="bfd0e5"/>
-                </a:solidFill>
-                <a:latin typeface="Inter"/>
-                <a:ea typeface="Inter"/>
-              </a:rPr>
-              <a:t>IOT SENSORS / CARBON CREDITS VIEW</a:t>
-            </a:r>
-            <a:endParaRPr b="0" lang="en-US" sz="1200" spc="-1" strike="noStrike">
-              <a:solidFill>
-                <a:srgbClr val="ffffff"/>
-              </a:solidFill>
-              <a:latin typeface="Arial"/>
-            </a:endParaRPr>
-          </a:p>
-        </p:txBody>
-      </p:sp>
-      <p:sp>
-        <p:nvSpPr>
-          <p:cNvPr id="260" name="Text 27"/>
-          <p:cNvSpPr/>
-          <p:nvPr/>
-        </p:nvSpPr>
-        <p:spPr>
-          <a:xfrm>
-            <a:off x="7223760" y="3328560"/>
-            <a:ext cx="1517400" cy="319680"/>
-          </a:xfrm>
-          <a:prstGeom prst="rect">
-            <a:avLst/>
-          </a:prstGeom>
-          <a:noFill/>
-          <a:ln w="0">
-            <a:noFill/>
-          </a:ln>
-        </p:spPr>
-        <p:style>
-          <a:lnRef idx="0"/>
-          <a:fillRef idx="0"/>
-          <a:effectRef idx="0"/>
-          <a:fontRef idx="minor"/>
-        </p:style>
-        <p:txBody>
-          <a:bodyPr lIns="0" rIns="0" tIns="0" bIns="0" anchor="ctr">
-            <a:normAutofit fontScale="87222" lnSpcReduction="10000"/>
-          </a:bodyPr>
-          <a:p>
-            <a:pPr algn="ctr" defTabSz="914400">
-              <a:lnSpc>
-                <a:spcPct val="100000"/>
-              </a:lnSpc>
-              <a:tabLst>
-                <a:tab algn="l" pos="0"/>
-              </a:tabLst>
-            </a:pPr>
-            <a:r>
-              <a:rPr b="0" lang="en-US" sz="870" spc="-1" strike="noStrike">
-                <a:solidFill>
-                  <a:srgbClr val="8faac9"/>
-                </a:solidFill>
-                <a:latin typeface="Roboto"/>
-                <a:ea typeface="Roboto"/>
-              </a:rPr>
-              <a:t>Replace this box with a readable screenshot / prototype image</a:t>
-            </a:r>
-            <a:endParaRPr b="0" lang="en-US" sz="870" spc="-1" strike="noStrike">
-              <a:solidFill>
-                <a:srgbClr val="ffffff"/>
-              </a:solidFill>
-              <a:latin typeface="Arial"/>
-            </a:endParaRPr>
-          </a:p>
-        </p:txBody>
-      </p:sp>
-      <p:sp>
-        <p:nvSpPr>
           <p:cNvPr id="261" name="Shape 28"/>
           <p:cNvSpPr/>
           <p:nvPr/>
@@ -16133,120 +15860,6 @@
                 <a:schemeClr val="dk1"/>
               </a:solidFill>
               <a:latin typeface="Roboto"/>
-            </a:endParaRPr>
-          </a:p>
-        </p:txBody>
-      </p:sp>
-      <p:sp>
-        <p:nvSpPr>
-          <p:cNvPr id="266" name="Text 33"/>
-          <p:cNvSpPr/>
-          <p:nvPr/>
-        </p:nvSpPr>
-        <p:spPr>
-          <a:xfrm>
-            <a:off x="9546480" y="3072240"/>
-            <a:ext cx="1425960" cy="228240"/>
-          </a:xfrm>
-          <a:prstGeom prst="rect">
-            <a:avLst/>
-          </a:prstGeom>
-          <a:noFill/>
-          <a:ln w="0">
-            <a:noFill/>
-          </a:ln>
-        </p:spPr>
-        <p:style>
-          <a:lnRef idx="0"/>
-          <a:fillRef idx="0"/>
-          <a:effectRef idx="0"/>
-          <a:fontRef idx="minor"/>
-        </p:style>
-        <p:txBody>
-          <a:bodyPr lIns="0" rIns="0" tIns="0" bIns="0" anchor="ctr">
-            <a:normAutofit fontScale="68333"/>
-          </a:bodyPr>
-          <a:p>
-            <a:pPr algn="ctr" defTabSz="914400">
-              <a:lnSpc>
-                <a:spcPct val="100000"/>
-              </a:lnSpc>
-              <a:tabLst>
-                <a:tab algn="l" pos="0"/>
-              </a:tabLst>
-            </a:pPr>
-            <a:r>
-              <a:rPr b="1" lang="en-US" sz="1200" spc="-1" strike="noStrike">
-                <a:solidFill>
-                  <a:srgbClr val="bfd0e5"/>
-                </a:solidFill>
-                <a:latin typeface="Inter"/>
-                <a:ea typeface="Inter"/>
-              </a:rPr>
-              <a:t>ORDER LIFECYCLE &amp; TRUST LEDGER</a:t>
-            </a:r>
-            <a:endParaRPr b="0" lang="en-US" sz="1200" spc="-1" strike="noStrike">
-              <a:solidFill>
-                <a:srgbClr val="ffffff"/>
-              </a:solidFill>
-              <a:latin typeface="Arial"/>
-            </a:endParaRPr>
-          </a:p>
-        </p:txBody>
-      </p:sp>
-      <p:sp>
-        <p:nvSpPr>
-          <p:cNvPr id="267" name="Text 34"/>
-          <p:cNvSpPr/>
-          <p:nvPr/>
-        </p:nvSpPr>
-        <p:spPr>
-          <a:xfrm>
-            <a:off x="9564480" y="3328560"/>
-            <a:ext cx="1389600" cy="319680"/>
-          </a:xfrm>
-          <a:prstGeom prst="rect">
-            <a:avLst/>
-          </a:prstGeom>
-          <a:noFill/>
-          <a:ln w="0">
-            <a:noFill/>
-          </a:ln>
-        </p:spPr>
-        <p:style>
-          <a:lnRef idx="0"/>
-          <a:fillRef idx="0"/>
-          <a:effectRef idx="0"/>
-          <a:fontRef idx="minor"/>
-        </p:style>
-        <p:txBody>
-          <a:bodyPr lIns="0" rIns="0" tIns="0" bIns="0" anchor="ctr">
-            <a:normAutofit fontScale="87222" lnSpcReduction="10000"/>
-          </a:bodyPr>
-          <a:p>
-            <a:pPr algn="ctr" defTabSz="914400">
-              <a:lnSpc>
-                <a:spcPct val="100000"/>
-              </a:lnSpc>
-              <a:tabLst>
-                <a:tab algn="l" pos="0"/>
-              </a:tabLst>
-            </a:pPr>
-            <a:r>
-              <a:rPr b="0" lang="en-US" sz="870" spc="-1" strike="noStrike">
-                <a:solidFill>
-                  <a:srgbClr val="8faac9"/>
-                </a:solidFill>
-                <a:latin typeface="Roboto"/>
-                <a:ea typeface="Roboto"/>
-              </a:rPr>
-              <a:t>Replace this box with a readable screenshot / prototype image</a:t>
-            </a:r>
-            <a:endParaRPr b="0" lang="en-US" sz="870" spc="-1" strike="noStrike">
-              <a:solidFill>
-                <a:srgbClr val="ffffff"/>
-              </a:solidFill>
-              <a:latin typeface="Arial"/>
             </a:endParaRPr>
           </a:p>
         </p:txBody>
@@ -16610,13 +16223,17 @@
       </p:sp>
       <p:pic>
         <p:nvPicPr>
-          <p:cNvPr id="273" name="Picture 41" descr="dashboard_screenshot.png"/>
-          <p:cNvPicPr/>
+          <p:cNvPr id="273" name="Picture 272" descr="matching_engine.png"/>
+          <p:cNvPicPr>
+            <a:picLocks noChangeAspect="1"/>
+          </p:cNvPicPr>
           <p:nvPr/>
         </p:nvPicPr>
         <p:blipFill>
-          <a:blip r:embed="rId1"/>
-          <a:stretch/>
+          <a:blip r:embed="rId4"/>
+          <a:stretch>
+            <a:fillRect/>
+          </a:stretch>
         </p:blipFill>
         <p:spPr>
           <a:xfrm>
@@ -16626,9 +16243,54 @@
           <a:prstGeom prst="rect">
             <a:avLst/>
           </a:prstGeom>
-          <a:ln w="0">
-            <a:noFill/>
-          </a:ln>
+        </p:spPr>
+      </p:pic>
+      <p:pic>
+        <p:nvPicPr>
+          <p:cNvPr id="274" name="Picture 273" descr="iot_sensors.png"/>
+          <p:cNvPicPr>
+            <a:picLocks noChangeAspect="1"/>
+          </p:cNvPicPr>
+          <p:nvPr/>
+        </p:nvPicPr>
+        <p:blipFill>
+          <a:blip r:embed="rId5"/>
+          <a:stretch>
+            <a:fillRect/>
+          </a:stretch>
+        </p:blipFill>
+        <p:spPr>
+          <a:xfrm>
+            <a:off x="7115494" y="2871000"/>
+            <a:ext cx="1733932" cy="822960"/>
+          </a:xfrm>
+          <a:prstGeom prst="rect">
+            <a:avLst/>
+          </a:prstGeom>
+        </p:spPr>
+      </p:pic>
+      <p:pic>
+        <p:nvPicPr>
+          <p:cNvPr id="275" name="Picture 274" descr="orders.png"/>
+          <p:cNvPicPr>
+            <a:picLocks noChangeAspect="1"/>
+          </p:cNvPicPr>
+          <p:nvPr/>
+        </p:nvPicPr>
+        <p:blipFill>
+          <a:blip r:embed="rId6"/>
+          <a:stretch>
+            <a:fillRect/>
+          </a:stretch>
+        </p:blipFill>
+        <p:spPr>
+          <a:xfrm>
+            <a:off x="9455040" y="2898104"/>
+            <a:ext cx="1608840" cy="768751"/>
+          </a:xfrm>
+          <a:prstGeom prst="rect">
+            <a:avLst/>
+          </a:prstGeom>
         </p:spPr>
       </p:pic>
     </p:spTree>

</xml_diff>